<commit_message>
Added strict to load model
</commit_message>
<xml_diff>
--- a/docs/combining_wavelets_to_resnet.pptx
+++ b/docs/combining_wavelets_to_resnet.pptx
@@ -5,7 +5,7 @@
     <p:sldMasterId id="2147483768" r:id="rId1"/>
   </p:sldMasterIdLst>
   <p:notesMasterIdLst>
-    <p:notesMasterId r:id="rId13"/>
+    <p:notesMasterId r:id="rId15"/>
   </p:notesMasterIdLst>
   <p:sldIdLst>
     <p:sldId id="256" r:id="rId2"/>
@@ -18,7 +18,9 @@
     <p:sldId id="263" r:id="rId9"/>
     <p:sldId id="265" r:id="rId10"/>
     <p:sldId id="266" r:id="rId11"/>
-    <p:sldId id="264" r:id="rId12"/>
+    <p:sldId id="267" r:id="rId12"/>
+    <p:sldId id="268" r:id="rId13"/>
+    <p:sldId id="264" r:id="rId14"/>
   </p:sldIdLst>
   <p:sldSz cx="12192000" cy="6858000"/>
   <p:notesSz cx="6858000" cy="9144000"/>
@@ -117,13 +119,18 @@
       </a:defRPr>
     </a:lvl9pPr>
   </p:defaultTextStyle>
+  <p:extLst>
+    <p:ext uri="{EFAFB233-063F-42B5-8137-9DF3F51BA10A}">
+      <p15:sldGuideLst xmlns:p15="http://schemas.microsoft.com/office/powerpoint/2012/main"/>
+    </p:ext>
+  </p:extLst>
 </p:presentation>
 </file>
 
 <file path=ppt/revisionInfo.xml><?xml version="1.0" encoding="utf-8"?>
 <p1510:revInfo xmlns:a="http://schemas.openxmlformats.org/drawingml/2006/main" xmlns:r="http://schemas.openxmlformats.org/officeDocument/2006/relationships" xmlns:p1510="http://schemas.microsoft.com/office/powerpoint/2015/10/main">
   <p1510:revLst>
-    <p1510:client id="{28CAF153-B931-4070-9F19-21D537F84DD3}" v="45" dt="2026-01-25T18:07:32.425"/>
+    <p1510:client id="{28CAF153-B931-4070-9F19-21D537F84DD3}" v="68" dt="2026-01-26T08:25:30.213"/>
   </p1510:revLst>
 </p1510:revInfo>
 </file>
@@ -133,7 +140,7 @@
   <pc:docChgLst>
     <pc:chgData name="Barak Telem" userId="d0a7f981-39a6-47ea-b324-5cf2fd258e29" providerId="ADAL" clId="{567EB390-9C4D-4B7A-B7CE-EE18F96FBDC9}"/>
     <pc:docChg chg="undo custSel addSld delSld modSld sldOrd">
-      <pc:chgData name="Barak Telem" userId="d0a7f981-39a6-47ea-b324-5cf2fd258e29" providerId="ADAL" clId="{567EB390-9C4D-4B7A-B7CE-EE18F96FBDC9}" dt="2026-01-25T18:07:37.151" v="1308" actId="20577"/>
+      <pc:chgData name="Barak Telem" userId="d0a7f981-39a6-47ea-b324-5cf2fd258e29" providerId="ADAL" clId="{567EB390-9C4D-4B7A-B7CE-EE18F96FBDC9}" dt="2026-01-26T08:32:28.801" v="1943" actId="313"/>
       <pc:docMkLst>
         <pc:docMk/>
       </pc:docMkLst>
@@ -479,20 +486,75 @@
           </ac:spMkLst>
         </pc:spChg>
       </pc:sldChg>
-      <pc:sldChg chg="modSp new mod">
-        <pc:chgData name="Barak Telem" userId="d0a7f981-39a6-47ea-b324-5cf2fd258e29" providerId="ADAL" clId="{567EB390-9C4D-4B7A-B7CE-EE18F96FBDC9}" dt="2026-01-25T13:25:39.638" v="523" actId="20577"/>
+      <pc:sldChg chg="addSp modSp new mod setBg modNotesTx">
+        <pc:chgData name="Barak Telem" userId="d0a7f981-39a6-47ea-b324-5cf2fd258e29" providerId="ADAL" clId="{567EB390-9C4D-4B7A-B7CE-EE18F96FBDC9}" dt="2026-01-26T08:22:07.327" v="1534" actId="1076"/>
         <pc:sldMkLst>
           <pc:docMk/>
           <pc:sldMk cId="1791042911" sldId="266"/>
         </pc:sldMkLst>
         <pc:spChg chg="mod">
-          <ac:chgData name="Barak Telem" userId="d0a7f981-39a6-47ea-b324-5cf2fd258e29" providerId="ADAL" clId="{567EB390-9C4D-4B7A-B7CE-EE18F96FBDC9}" dt="2026-01-25T13:25:39.638" v="523" actId="20577"/>
+          <ac:chgData name="Barak Telem" userId="d0a7f981-39a6-47ea-b324-5cf2fd258e29" providerId="ADAL" clId="{567EB390-9C4D-4B7A-B7CE-EE18F96FBDC9}" dt="2026-01-26T08:16:05.928" v="1418" actId="26606"/>
           <ac:spMkLst>
             <pc:docMk/>
             <pc:sldMk cId="1791042911" sldId="266"/>
             <ac:spMk id="2" creationId="{5C6FEA68-3F3A-4FEC-F5DE-B16E5D54D24D}"/>
           </ac:spMkLst>
         </pc:spChg>
+        <pc:spChg chg="mod">
+          <ac:chgData name="Barak Telem" userId="d0a7f981-39a6-47ea-b324-5cf2fd258e29" providerId="ADAL" clId="{567EB390-9C4D-4B7A-B7CE-EE18F96FBDC9}" dt="2026-01-26T08:16:35.432" v="1423" actId="1076"/>
+          <ac:spMkLst>
+            <pc:docMk/>
+            <pc:sldMk cId="1791042911" sldId="266"/>
+            <ac:spMk id="3" creationId="{6972383C-5982-BE7C-1C79-5EC0690F9034}"/>
+          </ac:spMkLst>
+        </pc:spChg>
+        <pc:picChg chg="add mod">
+          <ac:chgData name="Barak Telem" userId="d0a7f981-39a6-47ea-b324-5cf2fd258e29" providerId="ADAL" clId="{567EB390-9C4D-4B7A-B7CE-EE18F96FBDC9}" dt="2026-01-26T08:22:07.327" v="1534" actId="1076"/>
+          <ac:picMkLst>
+            <pc:docMk/>
+            <pc:sldMk cId="1791042911" sldId="266"/>
+            <ac:picMk id="1026" creationId="{F082E2BC-EF6F-BFC3-A68D-8F38D8680A32}"/>
+          </ac:picMkLst>
+        </pc:picChg>
+      </pc:sldChg>
+      <pc:sldChg chg="addSp delSp modSp add mod">
+        <pc:chgData name="Barak Telem" userId="d0a7f981-39a6-47ea-b324-5cf2fd258e29" providerId="ADAL" clId="{567EB390-9C4D-4B7A-B7CE-EE18F96FBDC9}" dt="2026-01-26T08:29:08.782" v="1797" actId="20577"/>
+        <pc:sldMkLst>
+          <pc:docMk/>
+          <pc:sldMk cId="953616327" sldId="267"/>
+        </pc:sldMkLst>
+        <pc:spChg chg="mod">
+          <ac:chgData name="Barak Telem" userId="d0a7f981-39a6-47ea-b324-5cf2fd258e29" providerId="ADAL" clId="{567EB390-9C4D-4B7A-B7CE-EE18F96FBDC9}" dt="2026-01-26T08:29:08.782" v="1797" actId="20577"/>
+          <ac:spMkLst>
+            <pc:docMk/>
+            <pc:sldMk cId="953616327" sldId="267"/>
+            <ac:spMk id="3" creationId="{F86D79B6-047E-7E31-2CE1-DC7DC498B411}"/>
+          </ac:spMkLst>
+        </pc:spChg>
+        <pc:picChg chg="del">
+          <ac:chgData name="Barak Telem" userId="d0a7f981-39a6-47ea-b324-5cf2fd258e29" providerId="ADAL" clId="{567EB390-9C4D-4B7A-B7CE-EE18F96FBDC9}" dt="2026-01-26T08:16:54.048" v="1427" actId="478"/>
+          <ac:picMkLst>
+            <pc:docMk/>
+            <pc:sldMk cId="953616327" sldId="267"/>
+            <ac:picMk id="1026" creationId="{D32C5995-78E5-4572-DC47-98332DBB5AAF}"/>
+          </ac:picMkLst>
+        </pc:picChg>
+        <pc:picChg chg="add del mod">
+          <ac:chgData name="Barak Telem" userId="d0a7f981-39a6-47ea-b324-5cf2fd258e29" providerId="ADAL" clId="{567EB390-9C4D-4B7A-B7CE-EE18F96FBDC9}" dt="2026-01-26T08:25:13.613" v="1602" actId="478"/>
+          <ac:picMkLst>
+            <pc:docMk/>
+            <pc:sldMk cId="953616327" sldId="267"/>
+            <ac:picMk id="2050" creationId="{9E872D54-9F85-8EB4-7EC8-F13C1989DF57}"/>
+          </ac:picMkLst>
+        </pc:picChg>
+        <pc:picChg chg="add mod">
+          <ac:chgData name="Barak Telem" userId="d0a7f981-39a6-47ea-b324-5cf2fd258e29" providerId="ADAL" clId="{567EB390-9C4D-4B7A-B7CE-EE18F96FBDC9}" dt="2026-01-26T08:25:18.134" v="1606" actId="26606"/>
+          <ac:picMkLst>
+            <pc:docMk/>
+            <pc:sldMk cId="953616327" sldId="267"/>
+            <ac:picMk id="2052" creationId="{1D197467-7B2B-5FE4-AD86-40F720FDEA17}"/>
+          </ac:picMkLst>
+        </pc:picChg>
       </pc:sldChg>
       <pc:sldChg chg="modSp new del mod">
         <pc:chgData name="Barak Telem" userId="d0a7f981-39a6-47ea-b324-5cf2fd258e29" providerId="ADAL" clId="{567EB390-9C4D-4B7A-B7CE-EE18F96FBDC9}" dt="2026-01-25T17:54:22.137" v="1273" actId="2696"/>
@@ -516,6 +578,76 @@
             <ac:spMk id="3" creationId="{C662EB8A-BA16-672D-171B-6BBE6DEAA844}"/>
           </ac:spMkLst>
         </pc:spChg>
+      </pc:sldChg>
+      <pc:sldChg chg="addSp delSp modSp add del mod">
+        <pc:chgData name="Barak Telem" userId="d0a7f981-39a6-47ea-b324-5cf2fd258e29" providerId="ADAL" clId="{567EB390-9C4D-4B7A-B7CE-EE18F96FBDC9}" dt="2026-01-26T08:23:25.103" v="1572" actId="2890"/>
+        <pc:sldMkLst>
+          <pc:docMk/>
+          <pc:sldMk cId="824255429" sldId="268"/>
+        </pc:sldMkLst>
+        <pc:spChg chg="mod">
+          <ac:chgData name="Barak Telem" userId="d0a7f981-39a6-47ea-b324-5cf2fd258e29" providerId="ADAL" clId="{567EB390-9C4D-4B7A-B7CE-EE18F96FBDC9}" dt="2026-01-26T08:23:11.103" v="1564" actId="26606"/>
+          <ac:spMkLst>
+            <pc:docMk/>
+            <pc:sldMk cId="824255429" sldId="268"/>
+            <ac:spMk id="3" creationId="{928FCD22-6EA5-3F8B-A8E1-872E7C300536}"/>
+          </ac:spMkLst>
+        </pc:spChg>
+        <pc:picChg chg="add del">
+          <ac:chgData name="Barak Telem" userId="d0a7f981-39a6-47ea-b324-5cf2fd258e29" providerId="ADAL" clId="{567EB390-9C4D-4B7A-B7CE-EE18F96FBDC9}" dt="2026-01-26T08:23:22.598" v="1571" actId="478"/>
+          <ac:picMkLst>
+            <pc:docMk/>
+            <pc:sldMk cId="824255429" sldId="268"/>
+            <ac:picMk id="2050" creationId="{943F9CAE-5364-B452-9388-C285E6140DBF}"/>
+          </ac:picMkLst>
+        </pc:picChg>
+        <pc:picChg chg="add mod">
+          <ac:chgData name="Barak Telem" userId="d0a7f981-39a6-47ea-b324-5cf2fd258e29" providerId="ADAL" clId="{567EB390-9C4D-4B7A-B7CE-EE18F96FBDC9}" dt="2026-01-26T08:23:16.510" v="1566" actId="26606"/>
+          <ac:picMkLst>
+            <pc:docMk/>
+            <pc:sldMk cId="824255429" sldId="268"/>
+            <ac:picMk id="3074" creationId="{C342D062-3B3A-D9DE-C2A4-3D653B3CA06E}"/>
+          </ac:picMkLst>
+        </pc:picChg>
+      </pc:sldChg>
+      <pc:sldChg chg="addSp delSp modSp add mod addAnim delAnim">
+        <pc:chgData name="Barak Telem" userId="d0a7f981-39a6-47ea-b324-5cf2fd258e29" providerId="ADAL" clId="{567EB390-9C4D-4B7A-B7CE-EE18F96FBDC9}" dt="2026-01-26T08:32:28.801" v="1943" actId="313"/>
+        <pc:sldMkLst>
+          <pc:docMk/>
+          <pc:sldMk cId="2351415193" sldId="268"/>
+        </pc:sldMkLst>
+        <pc:spChg chg="mod">
+          <ac:chgData name="Barak Telem" userId="d0a7f981-39a6-47ea-b324-5cf2fd258e29" providerId="ADAL" clId="{567EB390-9C4D-4B7A-B7CE-EE18F96FBDC9}" dt="2026-01-26T08:32:28.801" v="1943" actId="313"/>
+          <ac:spMkLst>
+            <pc:docMk/>
+            <pc:sldMk cId="2351415193" sldId="268"/>
+            <ac:spMk id="3" creationId="{07734AE8-8BB2-6BBD-02AA-07DBF812620A}"/>
+          </ac:spMkLst>
+        </pc:spChg>
+        <pc:picChg chg="del">
+          <ac:chgData name="Barak Telem" userId="d0a7f981-39a6-47ea-b324-5cf2fd258e29" providerId="ADAL" clId="{567EB390-9C4D-4B7A-B7CE-EE18F96FBDC9}" dt="2026-01-26T08:24:23.115" v="1581" actId="478"/>
+          <ac:picMkLst>
+            <pc:docMk/>
+            <pc:sldMk cId="2351415193" sldId="268"/>
+            <ac:picMk id="2050" creationId="{63544A68-7798-6A5E-8AEA-EB908A6A7712}"/>
+          </ac:picMkLst>
+        </pc:picChg>
+        <pc:picChg chg="add del mod">
+          <ac:chgData name="Barak Telem" userId="d0a7f981-39a6-47ea-b324-5cf2fd258e29" providerId="ADAL" clId="{567EB390-9C4D-4B7A-B7CE-EE18F96FBDC9}" dt="2026-01-26T08:25:24.940" v="1610" actId="478"/>
+          <ac:picMkLst>
+            <pc:docMk/>
+            <pc:sldMk cId="2351415193" sldId="268"/>
+            <ac:picMk id="4098" creationId="{E89A32AD-1AD8-4259-B91A-F4E8FE40C271}"/>
+          </ac:picMkLst>
+        </pc:picChg>
+        <pc:picChg chg="add mod">
+          <ac:chgData name="Barak Telem" userId="d0a7f981-39a6-47ea-b324-5cf2fd258e29" providerId="ADAL" clId="{567EB390-9C4D-4B7A-B7CE-EE18F96FBDC9}" dt="2026-01-26T08:25:33.731" v="1617" actId="26606"/>
+          <ac:picMkLst>
+            <pc:docMk/>
+            <pc:sldMk cId="2351415193" sldId="268"/>
+            <ac:picMk id="4100" creationId="{4DD907B0-5D9A-9BBD-DD08-E9A08DE27F7D}"/>
+          </ac:picMkLst>
+        </pc:picChg>
       </pc:sldChg>
     </pc:docChg>
   </pc:docChgLst>
@@ -604,7 +736,7 @@
           <a:p>
             <a:fld id="{C42C6FCE-D002-436D-8E55-A8FB05112A43}" type="datetimeFigureOut">
               <a:rPr lang="en-US" smtClean="0"/>
-              <a:t>1/25/2026</a:t>
+              <a:t>1/26/2026</a:t>
             </a:fld>
             <a:endParaRPr lang="en-US"/>
           </a:p>
@@ -1449,6 +1581,120 @@
 </p:notes>
 </file>
 
+<file path=ppt/notesSlides/notesSlide3.xml><?xml version="1.0" encoding="utf-8"?>
+<p:notes xmlns:a="http://schemas.openxmlformats.org/drawingml/2006/main" xmlns:r="http://schemas.openxmlformats.org/officeDocument/2006/relationships" xmlns:p="http://schemas.openxmlformats.org/presentationml/2006/main">
+  <p:cSld>
+    <p:spTree>
+      <p:nvGrpSpPr>
+        <p:cNvPr id="1" name=""/>
+        <p:cNvGrpSpPr/>
+        <p:nvPr/>
+      </p:nvGrpSpPr>
+      <p:grpSpPr>
+        <a:xfrm>
+          <a:off x="0" y="0"/>
+          <a:ext cx="0" cy="0"/>
+          <a:chOff x="0" y="0"/>
+          <a:chExt cx="0" cy="0"/>
+        </a:xfrm>
+      </p:grpSpPr>
+      <p:sp>
+        <p:nvSpPr>
+          <p:cNvPr id="2" name="Slide Image Placeholder 1"/>
+          <p:cNvSpPr>
+            <a:spLocks noGrp="1" noRot="1" noChangeAspect="1"/>
+          </p:cNvSpPr>
+          <p:nvPr>
+            <p:ph type="sldImg"/>
+          </p:nvPr>
+        </p:nvSpPr>
+        <p:spPr/>
+      </p:sp>
+      <p:sp>
+        <p:nvSpPr>
+          <p:cNvPr id="3" name="Notes Placeholder 2"/>
+          <p:cNvSpPr>
+            <a:spLocks noGrp="1"/>
+          </p:cNvSpPr>
+          <p:nvPr>
+            <p:ph type="body" idx="1"/>
+          </p:nvPr>
+        </p:nvSpPr>
+        <p:spPr/>
+        <p:txBody>
+          <a:bodyPr/>
+          <a:lstStyle/>
+          <a:p>
+            <a:r>
+              <a:rPr lang="en-US" dirty="0"/>
+              <a:t>Models were trained with the following augmentations:</a:t>
+            </a:r>
+          </a:p>
+          <a:p>
+            <a:pPr marL="228600" indent="-228600">
+              <a:buAutoNum type="arabicPeriod"/>
+            </a:pPr>
+            <a:r>
+              <a:rPr lang="en-US" dirty="0"/>
+              <a:t>Horizontal flip</a:t>
+            </a:r>
+          </a:p>
+          <a:p>
+            <a:pPr marL="228600" indent="-228600">
+              <a:buAutoNum type="arabicPeriod"/>
+            </a:pPr>
+            <a:r>
+              <a:rPr lang="en-US" dirty="0"/>
+              <a:t>Color jitter</a:t>
+            </a:r>
+          </a:p>
+          <a:p>
+            <a:pPr marL="228600" indent="-228600">
+              <a:buAutoNum type="arabicPeriod"/>
+            </a:pPr>
+            <a:r>
+              <a:rPr lang="en-US" dirty="0"/>
+              <a:t>Resize crop</a:t>
+            </a:r>
+          </a:p>
+        </p:txBody>
+      </p:sp>
+      <p:sp>
+        <p:nvSpPr>
+          <p:cNvPr id="4" name="Slide Number Placeholder 3"/>
+          <p:cNvSpPr>
+            <a:spLocks noGrp="1"/>
+          </p:cNvSpPr>
+          <p:nvPr>
+            <p:ph type="sldNum" sz="quarter" idx="5"/>
+          </p:nvPr>
+        </p:nvSpPr>
+        <p:spPr/>
+        <p:txBody>
+          <a:bodyPr/>
+          <a:lstStyle/>
+          <a:p>
+            <a:fld id="{0AA00FFE-A4AB-4A46-BAB8-90238CCA276E}" type="slidenum">
+              <a:rPr lang="en-US" smtClean="0"/>
+              <a:t>10</a:t>
+            </a:fld>
+            <a:endParaRPr lang="en-US"/>
+          </a:p>
+        </p:txBody>
+      </p:sp>
+    </p:spTree>
+    <p:extLst>
+      <p:ext uri="{BB962C8B-B14F-4D97-AF65-F5344CB8AC3E}">
+        <p14:creationId xmlns:p14="http://schemas.microsoft.com/office/powerpoint/2010/main" val="100432477"/>
+      </p:ext>
+    </p:extLst>
+  </p:cSld>
+  <p:clrMapOvr>
+    <a:masterClrMapping/>
+  </p:clrMapOvr>
+</p:notes>
+</file>
+
 <file path=ppt/slideLayouts/slideLayout1.xml><?xml version="1.0" encoding="utf-8"?>
 <p:sldLayout xmlns:a="http://schemas.openxmlformats.org/drawingml/2006/main" xmlns:r="http://schemas.openxmlformats.org/officeDocument/2006/relationships" xmlns:p="http://schemas.openxmlformats.org/presentationml/2006/main" showMasterSp="0" type="title" preserve="1">
   <p:cSld name="Title Slide">
@@ -2144,7 +2390,7 @@
           <a:p>
             <a:fld id="{28BFC830-6E14-483E-88F0-DC4B9462840F}" type="datetimeFigureOut">
               <a:rPr lang="en-US" smtClean="0"/>
-              <a:t>1/25/2026</a:t>
+              <a:t>1/26/2026</a:t>
             </a:fld>
             <a:endParaRPr lang="en-US"/>
           </a:p>
@@ -3271,7 +3517,7 @@
           <a:p>
             <a:fld id="{28BFC830-6E14-483E-88F0-DC4B9462840F}" type="datetimeFigureOut">
               <a:rPr lang="en-US" smtClean="0"/>
-              <a:t>1/25/2026</a:t>
+              <a:t>1/26/2026</a:t>
             </a:fld>
             <a:endParaRPr lang="en-US"/>
           </a:p>
@@ -4282,7 +4528,7 @@
           <a:p>
             <a:fld id="{28BFC830-6E14-483E-88F0-DC4B9462840F}" type="datetimeFigureOut">
               <a:rPr lang="en-US" smtClean="0"/>
-              <a:t>1/25/2026</a:t>
+              <a:t>1/26/2026</a:t>
             </a:fld>
             <a:endParaRPr lang="en-US"/>
           </a:p>
@@ -5452,7 +5698,7 @@
           <a:p>
             <a:fld id="{28BFC830-6E14-483E-88F0-DC4B9462840F}" type="datetimeFigureOut">
               <a:rPr lang="en-US" smtClean="0"/>
-              <a:t>1/25/2026</a:t>
+              <a:t>1/26/2026</a:t>
             </a:fld>
             <a:endParaRPr lang="en-US"/>
           </a:p>
@@ -6513,7 +6759,7 @@
           <a:p>
             <a:fld id="{28BFC830-6E14-483E-88F0-DC4B9462840F}" type="datetimeFigureOut">
               <a:rPr lang="en-US" smtClean="0"/>
-              <a:t>1/25/2026</a:t>
+              <a:t>1/26/2026</a:t>
             </a:fld>
             <a:endParaRPr lang="en-US"/>
           </a:p>
@@ -7159,7 +7405,7 @@
           <a:p>
             <a:fld id="{28BFC830-6E14-483E-88F0-DC4B9462840F}" type="datetimeFigureOut">
               <a:rPr lang="en-US" smtClean="0"/>
-              <a:t>1/25/2026</a:t>
+              <a:t>1/26/2026</a:t>
             </a:fld>
             <a:endParaRPr lang="en-US"/>
           </a:p>
@@ -8006,7 +8252,7 @@
           <a:p>
             <a:fld id="{28BFC830-6E14-483E-88F0-DC4B9462840F}" type="datetimeFigureOut">
               <a:rPr lang="en-US" smtClean="0"/>
-              <a:t>1/25/2026</a:t>
+              <a:t>1/26/2026</a:t>
             </a:fld>
             <a:endParaRPr lang="en-US"/>
           </a:p>
@@ -8181,7 +8427,7 @@
           <a:p>
             <a:fld id="{28BFC830-6E14-483E-88F0-DC4B9462840F}" type="datetimeFigureOut">
               <a:rPr lang="en-US" smtClean="0"/>
-              <a:t>1/25/2026</a:t>
+              <a:t>1/26/2026</a:t>
             </a:fld>
             <a:endParaRPr lang="en-US"/>
           </a:p>
@@ -9179,7 +9425,7 @@
           <a:p>
             <a:fld id="{28BFC830-6E14-483E-88F0-DC4B9462840F}" type="datetimeFigureOut">
               <a:rPr lang="en-US" smtClean="0"/>
-              <a:t>1/25/2026</a:t>
+              <a:t>1/26/2026</a:t>
             </a:fld>
             <a:endParaRPr lang="en-US"/>
           </a:p>
@@ -9385,7 +9631,7 @@
           <a:p>
             <a:fld id="{28BFC830-6E14-483E-88F0-DC4B9462840F}" type="datetimeFigureOut">
               <a:rPr lang="en-US" smtClean="0"/>
-              <a:t>1/25/2026</a:t>
+              <a:t>1/26/2026</a:t>
             </a:fld>
             <a:endParaRPr lang="en-US"/>
           </a:p>
@@ -10447,7 +10693,7 @@
           <a:p>
             <a:fld id="{28BFC830-6E14-483E-88F0-DC4B9462840F}" type="datetimeFigureOut">
               <a:rPr lang="en-US" smtClean="0"/>
-              <a:t>1/25/2026</a:t>
+              <a:t>1/26/2026</a:t>
             </a:fld>
             <a:endParaRPr lang="en-US"/>
           </a:p>
@@ -10719,7 +10965,7 @@
           <a:p>
             <a:fld id="{28BFC830-6E14-483E-88F0-DC4B9462840F}" type="datetimeFigureOut">
               <a:rPr lang="en-US" smtClean="0"/>
-              <a:t>1/25/2026</a:t>
+              <a:t>1/26/2026</a:t>
             </a:fld>
             <a:endParaRPr lang="en-US"/>
           </a:p>
@@ -11101,7 +11347,7 @@
           <a:p>
             <a:fld id="{28BFC830-6E14-483E-88F0-DC4B9462840F}" type="datetimeFigureOut">
               <a:rPr lang="en-US" smtClean="0"/>
-              <a:t>1/25/2026</a:t>
+              <a:t>1/26/2026</a:t>
             </a:fld>
             <a:endParaRPr lang="en-US"/>
           </a:p>
@@ -11219,7 +11465,7 @@
           <a:p>
             <a:fld id="{28BFC830-6E14-483E-88F0-DC4B9462840F}" type="datetimeFigureOut">
               <a:rPr lang="en-US" smtClean="0"/>
-              <a:t>1/25/2026</a:t>
+              <a:t>1/26/2026</a:t>
             </a:fld>
             <a:endParaRPr lang="en-US"/>
           </a:p>
@@ -11314,7 +11560,7 @@
           <a:p>
             <a:fld id="{28BFC830-6E14-483E-88F0-DC4B9462840F}" type="datetimeFigureOut">
               <a:rPr lang="en-US" smtClean="0"/>
-              <a:t>1/25/2026</a:t>
+              <a:t>1/26/2026</a:t>
             </a:fld>
             <a:endParaRPr lang="en-US"/>
           </a:p>
@@ -12423,7 +12669,7 @@
           <a:p>
             <a:fld id="{28BFC830-6E14-483E-88F0-DC4B9462840F}" type="datetimeFigureOut">
               <a:rPr lang="en-US" smtClean="0"/>
-              <a:t>1/25/2026</a:t>
+              <a:t>1/26/2026</a:t>
             </a:fld>
             <a:endParaRPr lang="en-US"/>
           </a:p>
@@ -13556,7 +13802,7 @@
           <a:p>
             <a:fld id="{28BFC830-6E14-483E-88F0-DC4B9462840F}" type="datetimeFigureOut">
               <a:rPr lang="en-US" smtClean="0"/>
-              <a:t>1/25/2026</a:t>
+              <a:t>1/26/2026</a:t>
             </a:fld>
             <a:endParaRPr lang="en-US"/>
           </a:p>
@@ -14647,7 +14893,7 @@
           <a:p>
             <a:fld id="{28BFC830-6E14-483E-88F0-DC4B9462840F}" type="datetimeFigureOut">
               <a:rPr lang="en-US" smtClean="0"/>
-              <a:t>1/25/2026</a:t>
+              <a:t>1/26/2026</a:t>
             </a:fld>
             <a:endParaRPr lang="en-US"/>
           </a:p>
@@ -15554,6 +15800,14 @@
 <file path=ppt/slides/slide10.xml><?xml version="1.0" encoding="utf-8"?>
 <p:sld xmlns:a="http://schemas.openxmlformats.org/drawingml/2006/main" xmlns:r="http://schemas.openxmlformats.org/officeDocument/2006/relationships" xmlns:p="http://schemas.openxmlformats.org/presentationml/2006/main">
   <p:cSld>
+    <p:bg>
+      <p:bgPr>
+        <a:solidFill>
+          <a:schemeClr val="bg1"/>
+        </a:solidFill>
+        <a:effectLst/>
+      </p:bgPr>
+    </p:bg>
     <p:spTree>
       <p:nvGrpSpPr>
         <p:cNvPr id="1" name=""/>
@@ -15584,9 +15838,16 @@
             <p:ph type="title"/>
           </p:nvPr>
         </p:nvSpPr>
-        <p:spPr/>
+        <p:spPr>
+          <a:xfrm>
+            <a:off x="1154953" y="973668"/>
+            <a:ext cx="8761413" cy="706964"/>
+          </a:xfrm>
+        </p:spPr>
         <p:txBody>
-          <a:bodyPr/>
+          <a:bodyPr>
+            <a:normAutofit/>
+          </a:bodyPr>
           <a:lstStyle/>
           <a:p>
             <a:r>
@@ -15612,15 +15873,83 @@
             <p:ph idx="1"/>
           </p:nvPr>
         </p:nvSpPr>
-        <p:spPr/>
+        <p:spPr>
+          <a:xfrm>
+            <a:off x="1154953" y="2195420"/>
+            <a:ext cx="7875690" cy="3416300"/>
+          </a:xfrm>
+        </p:spPr>
         <p:txBody>
-          <a:bodyPr/>
+          <a:bodyPr anchor="ctr">
+            <a:normAutofit/>
+          </a:bodyPr>
           <a:lstStyle/>
           <a:p>
-            <a:endParaRPr lang="en-US"/>
+            <a:r>
+              <a:rPr lang="en-US" sz="1600" dirty="0"/>
+              <a:t>Augmentations that copy texture and positional changes</a:t>
+            </a:r>
+          </a:p>
+          <a:p>
+            <a:endParaRPr lang="en-US" sz="1600" dirty="0"/>
           </a:p>
         </p:txBody>
       </p:sp>
+      <p:pic>
+        <p:nvPicPr>
+          <p:cNvPr id="1026" name="Picture 2">
+            <a:extLst>
+              <a:ext uri="{FF2B5EF4-FFF2-40B4-BE49-F238E27FC236}">
+                <a16:creationId xmlns:a16="http://schemas.microsoft.com/office/drawing/2014/main" id="{F082E2BC-EF6F-BFC3-A68D-8F38D8680A32}"/>
+              </a:ext>
+            </a:extLst>
+          </p:cNvPr>
+          <p:cNvPicPr>
+            <a:picLocks noChangeAspect="1" noChangeArrowheads="1"/>
+          </p:cNvPicPr>
+          <p:nvPr/>
+        </p:nvPicPr>
+        <p:blipFill>
+          <a:blip r:embed="rId3">
+            <a:extLst>
+              <a:ext uri="{28A0092B-C50C-407E-A947-70E740481C1C}">
+                <a14:useLocalDpi xmlns:a14="http://schemas.microsoft.com/office/drawing/2010/main" val="0"/>
+              </a:ext>
+            </a:extLst>
+          </a:blip>
+          <a:stretch>
+            <a:fillRect/>
+          </a:stretch>
+        </p:blipFill>
+        <p:spPr bwMode="auto">
+          <a:xfrm>
+            <a:off x="1154953" y="4384083"/>
+            <a:ext cx="8322965" cy="1227637"/>
+          </a:xfrm>
+          <a:prstGeom prst="roundRect">
+            <a:avLst>
+              <a:gd name="adj" fmla="val 1858"/>
+            </a:avLst>
+          </a:prstGeom>
+          <a:noFill/>
+          <a:effectLst>
+            <a:outerShdw blurRad="50800" dist="50800" dir="5400000" algn="tl" rotWithShape="0">
+              <a:srgbClr val="000000">
+                <a:alpha val="43000"/>
+              </a:srgbClr>
+            </a:outerShdw>
+          </a:effectLst>
+          <a:extLst>
+            <a:ext uri="{909E8E84-426E-40DD-AFC4-6F175D3DCCD1}">
+              <a14:hiddenFill xmlns:a14="http://schemas.microsoft.com/office/drawing/2010/main">
+                <a:solidFill>
+                  <a:srgbClr val="FFFFFF"/>
+                </a:solidFill>
+              </a14:hiddenFill>
+            </a:ext>
+          </a:extLst>
+        </p:spPr>
+      </p:pic>
     </p:spTree>
     <p:extLst>
       <p:ext uri="{BB962C8B-B14F-4D97-AF65-F5344CB8AC3E}">
@@ -15635,6 +15964,388 @@
 </file>
 
 <file path=ppt/slides/slide11.xml><?xml version="1.0" encoding="utf-8"?>
+<p:sld xmlns:a="http://schemas.openxmlformats.org/drawingml/2006/main" xmlns:r="http://schemas.openxmlformats.org/officeDocument/2006/relationships" xmlns:p="http://schemas.openxmlformats.org/presentationml/2006/main">
+  <p:cSld>
+    <p:bg>
+      <p:bgPr>
+        <a:solidFill>
+          <a:schemeClr val="bg1"/>
+        </a:solidFill>
+        <a:effectLst/>
+      </p:bgPr>
+    </p:bg>
+    <p:spTree>
+      <p:nvGrpSpPr>
+        <p:cNvPr id="1" name="">
+          <a:extLst>
+            <a:ext uri="{FF2B5EF4-FFF2-40B4-BE49-F238E27FC236}">
+              <a16:creationId xmlns:a16="http://schemas.microsoft.com/office/drawing/2014/main" id="{151C7C92-ABC1-E9D2-1D33-9435AFABB973}"/>
+            </a:ext>
+          </a:extLst>
+        </p:cNvPr>
+        <p:cNvGrpSpPr/>
+        <p:nvPr/>
+      </p:nvGrpSpPr>
+      <p:grpSpPr>
+        <a:xfrm>
+          <a:off x="0" y="0"/>
+          <a:ext cx="0" cy="0"/>
+          <a:chOff x="0" y="0"/>
+          <a:chExt cx="0" cy="0"/>
+        </a:xfrm>
+      </p:grpSpPr>
+      <p:sp>
+        <p:nvSpPr>
+          <p:cNvPr id="2" name="Title 1">
+            <a:extLst>
+              <a:ext uri="{FF2B5EF4-FFF2-40B4-BE49-F238E27FC236}">
+                <a16:creationId xmlns:a16="http://schemas.microsoft.com/office/drawing/2014/main" id="{68F7DC82-E519-DB00-7864-12E533E9DD9E}"/>
+              </a:ext>
+            </a:extLst>
+          </p:cNvPr>
+          <p:cNvSpPr>
+            <a:spLocks noGrp="1"/>
+          </p:cNvSpPr>
+          <p:nvPr>
+            <p:ph type="title"/>
+          </p:nvPr>
+        </p:nvSpPr>
+        <p:spPr>
+          <a:xfrm>
+            <a:off x="1154953" y="973668"/>
+            <a:ext cx="8761413" cy="706964"/>
+          </a:xfrm>
+        </p:spPr>
+        <p:txBody>
+          <a:bodyPr>
+            <a:normAutofit/>
+          </a:bodyPr>
+          <a:lstStyle/>
+          <a:p>
+            <a:r>
+              <a:rPr lang="en-US" dirty="0"/>
+              <a:t>Results – Robustness</a:t>
+            </a:r>
+          </a:p>
+        </p:txBody>
+      </p:sp>
+      <p:sp>
+        <p:nvSpPr>
+          <p:cNvPr id="3" name="Content Placeholder 2">
+            <a:extLst>
+              <a:ext uri="{FF2B5EF4-FFF2-40B4-BE49-F238E27FC236}">
+                <a16:creationId xmlns:a16="http://schemas.microsoft.com/office/drawing/2014/main" id="{F86D79B6-047E-7E31-2CE1-DC7DC498B411}"/>
+              </a:ext>
+            </a:extLst>
+          </p:cNvPr>
+          <p:cNvSpPr>
+            <a:spLocks noGrp="1"/>
+          </p:cNvSpPr>
+          <p:nvPr>
+            <p:ph idx="1"/>
+          </p:nvPr>
+        </p:nvSpPr>
+        <p:spPr>
+          <a:xfrm>
+            <a:off x="1154954" y="2603500"/>
+            <a:ext cx="5211979" cy="3416300"/>
+          </a:xfrm>
+        </p:spPr>
+        <p:txBody>
+          <a:bodyPr anchor="ctr">
+            <a:normAutofit/>
+          </a:bodyPr>
+          <a:lstStyle/>
+          <a:p>
+            <a:r>
+              <a:rPr lang="en-US" dirty="0"/>
+              <a:t>Overall performance:</a:t>
+            </a:r>
+          </a:p>
+          <a:p>
+            <a:pPr lvl="1"/>
+            <a:r>
+              <a:rPr lang="en-US" dirty="0"/>
+              <a:t>In most cases scattering performs on par or better.</a:t>
+            </a:r>
+          </a:p>
+          <a:p>
+            <a:pPr lvl="1"/>
+            <a:r>
+              <a:rPr lang="en-US" dirty="0"/>
+              <a:t>Exception: Color changes (gray scale, Gaussian noise) hurts scattering performance</a:t>
+            </a:r>
+          </a:p>
+          <a:p>
+            <a:endParaRPr lang="en-US" dirty="0"/>
+          </a:p>
+        </p:txBody>
+      </p:sp>
+      <p:pic>
+        <p:nvPicPr>
+          <p:cNvPr id="2052" name="Picture 4">
+            <a:extLst>
+              <a:ext uri="{FF2B5EF4-FFF2-40B4-BE49-F238E27FC236}">
+                <a16:creationId xmlns:a16="http://schemas.microsoft.com/office/drawing/2014/main" id="{1D197467-7B2B-5FE4-AD86-40F720FDEA17}"/>
+              </a:ext>
+            </a:extLst>
+          </p:cNvPr>
+          <p:cNvPicPr>
+            <a:picLocks noChangeAspect="1" noChangeArrowheads="1"/>
+          </p:cNvPicPr>
+          <p:nvPr/>
+        </p:nvPicPr>
+        <p:blipFill>
+          <a:blip r:embed="rId2">
+            <a:extLst>
+              <a:ext uri="{28A0092B-C50C-407E-A947-70E740481C1C}">
+                <a14:useLocalDpi xmlns:a14="http://schemas.microsoft.com/office/drawing/2010/main" val="0"/>
+              </a:ext>
+            </a:extLst>
+          </a:blip>
+          <a:stretch>
+            <a:fillRect/>
+          </a:stretch>
+        </p:blipFill>
+        <p:spPr bwMode="auto">
+          <a:xfrm>
+            <a:off x="6798733" y="2870243"/>
+            <a:ext cx="4345024" cy="2878578"/>
+          </a:xfrm>
+          <a:prstGeom prst="roundRect">
+            <a:avLst>
+              <a:gd name="adj" fmla="val 1858"/>
+            </a:avLst>
+          </a:prstGeom>
+          <a:noFill/>
+          <a:effectLst>
+            <a:outerShdw blurRad="50800" dist="50800" dir="5400000" algn="tl" rotWithShape="0">
+              <a:srgbClr val="000000">
+                <a:alpha val="43000"/>
+              </a:srgbClr>
+            </a:outerShdw>
+          </a:effectLst>
+          <a:extLst>
+            <a:ext uri="{909E8E84-426E-40DD-AFC4-6F175D3DCCD1}">
+              <a14:hiddenFill xmlns:a14="http://schemas.microsoft.com/office/drawing/2010/main">
+                <a:solidFill>
+                  <a:srgbClr val="FFFFFF"/>
+                </a:solidFill>
+              </a14:hiddenFill>
+            </a:ext>
+          </a:extLst>
+        </p:spPr>
+      </p:pic>
+    </p:spTree>
+    <p:extLst>
+      <p:ext uri="{BB962C8B-B14F-4D97-AF65-F5344CB8AC3E}">
+        <p14:creationId xmlns:p14="http://schemas.microsoft.com/office/powerpoint/2010/main" val="953616327"/>
+      </p:ext>
+    </p:extLst>
+  </p:cSld>
+  <p:clrMapOvr>
+    <a:masterClrMapping/>
+  </p:clrMapOvr>
+</p:sld>
+</file>
+
+<file path=ppt/slides/slide12.xml><?xml version="1.0" encoding="utf-8"?>
+<p:sld xmlns:a="http://schemas.openxmlformats.org/drawingml/2006/main" xmlns:r="http://schemas.openxmlformats.org/officeDocument/2006/relationships" xmlns:p="http://schemas.openxmlformats.org/presentationml/2006/main">
+  <p:cSld>
+    <p:bg>
+      <p:bgPr>
+        <a:solidFill>
+          <a:schemeClr val="bg1"/>
+        </a:solidFill>
+        <a:effectLst/>
+      </p:bgPr>
+    </p:bg>
+    <p:spTree>
+      <p:nvGrpSpPr>
+        <p:cNvPr id="1" name="">
+          <a:extLst>
+            <a:ext uri="{FF2B5EF4-FFF2-40B4-BE49-F238E27FC236}">
+              <a16:creationId xmlns:a16="http://schemas.microsoft.com/office/drawing/2014/main" id="{28662BB8-8C61-9F89-FBC4-E258B87E9ACA}"/>
+            </a:ext>
+          </a:extLst>
+        </p:cNvPr>
+        <p:cNvGrpSpPr/>
+        <p:nvPr/>
+      </p:nvGrpSpPr>
+      <p:grpSpPr>
+        <a:xfrm>
+          <a:off x="0" y="0"/>
+          <a:ext cx="0" cy="0"/>
+          <a:chOff x="0" y="0"/>
+          <a:chExt cx="0" cy="0"/>
+        </a:xfrm>
+      </p:grpSpPr>
+      <p:sp>
+        <p:nvSpPr>
+          <p:cNvPr id="2" name="Title 1">
+            <a:extLst>
+              <a:ext uri="{FF2B5EF4-FFF2-40B4-BE49-F238E27FC236}">
+                <a16:creationId xmlns:a16="http://schemas.microsoft.com/office/drawing/2014/main" id="{A3BE786C-1593-51CC-4414-204367B5BBB6}"/>
+              </a:ext>
+            </a:extLst>
+          </p:cNvPr>
+          <p:cNvSpPr>
+            <a:spLocks noGrp="1"/>
+          </p:cNvSpPr>
+          <p:nvPr>
+            <p:ph type="title"/>
+          </p:nvPr>
+        </p:nvSpPr>
+        <p:spPr>
+          <a:xfrm>
+            <a:off x="1154953" y="973668"/>
+            <a:ext cx="8761413" cy="706964"/>
+          </a:xfrm>
+        </p:spPr>
+        <p:txBody>
+          <a:bodyPr>
+            <a:normAutofit/>
+          </a:bodyPr>
+          <a:lstStyle/>
+          <a:p>
+            <a:r>
+              <a:rPr lang="en-US" dirty="0"/>
+              <a:t>Results – Robustness</a:t>
+            </a:r>
+          </a:p>
+        </p:txBody>
+      </p:sp>
+      <p:sp>
+        <p:nvSpPr>
+          <p:cNvPr id="3" name="Content Placeholder 2">
+            <a:extLst>
+              <a:ext uri="{FF2B5EF4-FFF2-40B4-BE49-F238E27FC236}">
+                <a16:creationId xmlns:a16="http://schemas.microsoft.com/office/drawing/2014/main" id="{07734AE8-8BB2-6BBD-02AA-07DBF812620A}"/>
+              </a:ext>
+            </a:extLst>
+          </p:cNvPr>
+          <p:cNvSpPr>
+            <a:spLocks noGrp="1"/>
+          </p:cNvSpPr>
+          <p:nvPr>
+            <p:ph idx="1"/>
+          </p:nvPr>
+        </p:nvSpPr>
+        <p:spPr>
+          <a:xfrm>
+            <a:off x="1154954" y="2603500"/>
+            <a:ext cx="5211979" cy="3416300"/>
+          </a:xfrm>
+        </p:spPr>
+        <p:txBody>
+          <a:bodyPr anchor="ctr">
+            <a:normAutofit/>
+          </a:bodyPr>
+          <a:lstStyle/>
+          <a:p>
+            <a:r>
+              <a:rPr lang="en-US" dirty="0"/>
+              <a:t>Accuracy drop</a:t>
+            </a:r>
+          </a:p>
+          <a:p>
+            <a:r>
+              <a:rPr lang="en-US" dirty="0"/>
+              <a:t>In big data regimes:</a:t>
+            </a:r>
+          </a:p>
+          <a:p>
+            <a:pPr lvl="1"/>
+            <a:r>
+              <a:rPr lang="en-US" dirty="0"/>
+              <a:t>Positional change- Degrades the same</a:t>
+            </a:r>
+          </a:p>
+          <a:p>
+            <a:pPr lvl="1"/>
+            <a:r>
+              <a:rPr lang="en-US" dirty="0"/>
+              <a:t>Color change- Scattering hurts</a:t>
+            </a:r>
+          </a:p>
+          <a:p>
+            <a:pPr lvl="1"/>
+            <a:r>
+              <a:rPr lang="en-US" dirty="0"/>
+              <a:t>Blurring- Scattering helps</a:t>
+            </a:r>
+          </a:p>
+        </p:txBody>
+      </p:sp>
+      <p:pic>
+        <p:nvPicPr>
+          <p:cNvPr id="4100" name="Picture 4">
+            <a:extLst>
+              <a:ext uri="{FF2B5EF4-FFF2-40B4-BE49-F238E27FC236}">
+                <a16:creationId xmlns:a16="http://schemas.microsoft.com/office/drawing/2014/main" id="{4DD907B0-5D9A-9BBD-DD08-E9A08DE27F7D}"/>
+              </a:ext>
+            </a:extLst>
+          </p:cNvPr>
+          <p:cNvPicPr>
+            <a:picLocks noChangeAspect="1" noChangeArrowheads="1"/>
+          </p:cNvPicPr>
+          <p:nvPr/>
+        </p:nvPicPr>
+        <p:blipFill>
+          <a:blip r:embed="rId2">
+            <a:extLst>
+              <a:ext uri="{28A0092B-C50C-407E-A947-70E740481C1C}">
+                <a14:useLocalDpi xmlns:a14="http://schemas.microsoft.com/office/drawing/2010/main" val="0"/>
+              </a:ext>
+            </a:extLst>
+          </a:blip>
+          <a:stretch>
+            <a:fillRect/>
+          </a:stretch>
+        </p:blipFill>
+        <p:spPr bwMode="auto">
+          <a:xfrm>
+            <a:off x="6798733" y="2875674"/>
+            <a:ext cx="4345024" cy="2867716"/>
+          </a:xfrm>
+          <a:prstGeom prst="roundRect">
+            <a:avLst>
+              <a:gd name="adj" fmla="val 1858"/>
+            </a:avLst>
+          </a:prstGeom>
+          <a:noFill/>
+          <a:effectLst>
+            <a:outerShdw blurRad="50800" dist="50800" dir="5400000" algn="tl" rotWithShape="0">
+              <a:srgbClr val="000000">
+                <a:alpha val="43000"/>
+              </a:srgbClr>
+            </a:outerShdw>
+          </a:effectLst>
+          <a:extLst>
+            <a:ext uri="{909E8E84-426E-40DD-AFC4-6F175D3DCCD1}">
+              <a14:hiddenFill xmlns:a14="http://schemas.microsoft.com/office/drawing/2010/main">
+                <a:solidFill>
+                  <a:srgbClr val="FFFFFF"/>
+                </a:solidFill>
+              </a14:hiddenFill>
+            </a:ext>
+          </a:extLst>
+        </p:spPr>
+      </p:pic>
+    </p:spTree>
+    <p:extLst>
+      <p:ext uri="{BB962C8B-B14F-4D97-AF65-F5344CB8AC3E}">
+        <p14:creationId xmlns:p14="http://schemas.microsoft.com/office/powerpoint/2010/main" val="2351415193"/>
+      </p:ext>
+    </p:extLst>
+  </p:cSld>
+  <p:clrMapOvr>
+    <a:masterClrMapping/>
+  </p:clrMapOvr>
+</p:sld>
+</file>
+
+<file path=ppt/slides/slide13.xml><?xml version="1.0" encoding="utf-8"?>
 <p:sld xmlns:a="http://schemas.openxmlformats.org/drawingml/2006/main" xmlns:r="http://schemas.openxmlformats.org/officeDocument/2006/relationships" xmlns:p="http://schemas.openxmlformats.org/presentationml/2006/main">
   <p:cSld>
     <p:spTree>

</xml_diff>